<commit_message>
deck: insert live screenshots — homepage (S3), Live Pulse + Jarvis (S7); fix S6 WhatsApp line
</commit_message>
<xml_diff>
--- a/Documents/WorkitSA - FNB Hackathon Deck.pptx
+++ b/Documents/WorkitSA - FNB Hackathon Deck.pptx
@@ -6264,119 +6264,6 @@
       </p:sp>
       <p:sp>
         <p:nvSpPr>
-          <p:cNvPr id="7" name="Rounded Rectangle 6"/>
-          <p:cNvSpPr/>
-          <p:nvPr/>
-        </p:nvSpPr>
-        <p:spPr>
-          <a:xfrm>
-            <a:off x="6812280" y="1783080"/>
-            <a:ext cx="4800600" cy="4297680"/>
-          </a:xfrm>
-          <a:prstGeom prst="roundRect">
-            <a:avLst/>
-          </a:prstGeom>
-          <a:solidFill>
-            <a:srgbClr val="FFFFFF"/>
-          </a:solidFill>
-          <a:ln w="19050">
-            <a:solidFill>
-              <a:srgbClr val="F5DBB5"/>
-            </a:solidFill>
-          </a:ln>
-          <a:effectLst/>
-        </p:spPr>
-        <p:style>
-          <a:lnRef idx="1">
-            <a:schemeClr val="accent1"/>
-          </a:lnRef>
-          <a:fillRef idx="3">
-            <a:schemeClr val="accent1"/>
-          </a:fillRef>
-          <a:effectRef idx="2">
-            <a:schemeClr val="accent1"/>
-          </a:effectRef>
-          <a:fontRef idx="minor">
-            <a:schemeClr val="lt1"/>
-          </a:fontRef>
-        </p:style>
-        <p:txBody>
-          <a:bodyPr rtlCol="0" anchor="ctr"/>
-          <a:lstStyle/>
-          <a:p>
-            <a:pPr algn="ctr"/>
-          </a:p>
-        </p:txBody>
-      </p:sp>
-      <p:sp>
-        <p:nvSpPr>
-          <p:cNvPr id="8" name="TextBox 7"/>
-          <p:cNvSpPr txBox="1"/>
-          <p:nvPr/>
-        </p:nvSpPr>
-        <p:spPr>
-          <a:xfrm>
-            <a:off x="6812280" y="3520440"/>
-            <a:ext cx="4800600" cy="822960"/>
-          </a:xfrm>
-          <a:prstGeom prst="rect">
-            <a:avLst/>
-          </a:prstGeom>
-          <a:noFill/>
-        </p:spPr>
-        <p:txBody>
-          <a:bodyPr wrap="square" anchor="ctr">
-            <a:spAutoFit/>
-          </a:bodyPr>
-          <a:lstStyle/>
-          <a:p>
-            <a:pPr algn="ctr">
-              <a:lnSpc>
-                <a:spcPct val="105000"/>
-              </a:lnSpc>
-              <a:spcBef>
-                <a:spcPts val="0"/>
-              </a:spcBef>
-              <a:spcAft>
-                <a:spcPts val="200"/>
-              </a:spcAft>
-            </a:pPr>
-            <a:r>
-              <a:rPr sz="1300" b="1" i="0">
-                <a:solidFill>
-                  <a:srgbClr val="8A7A6A"/>
-                </a:solidFill>
-                <a:latin typeface="Calibri"/>
-              </a:rPr>
-              <a:t>[ SCREENSHOT ]</a:t>
-            </a:r>
-          </a:p>
-          <a:p>
-            <a:pPr algn="ctr">
-              <a:lnSpc>
-                <a:spcPct val="105000"/>
-              </a:lnSpc>
-              <a:spcBef>
-                <a:spcPts val="0"/>
-              </a:spcBef>
-              <a:spcAft>
-                <a:spcPts val="200"/>
-              </a:spcAft>
-            </a:pPr>
-            <a:r>
-              <a:rPr sz="1100" b="0" i="0">
-                <a:solidFill>
-                  <a:srgbClr val="8A7A6A"/>
-                </a:solidFill>
-                <a:latin typeface="Calibri"/>
-              </a:rPr>
-              <a:t>find-work job feed on a phone (workitsa.co.za/find-work)</a:t>
-            </a:r>
-          </a:p>
-        </p:txBody>
-      </p:sp>
-      <p:sp>
-        <p:nvSpPr>
           <p:cNvPr id="9" name="Rounded Rectangle 8"/>
           <p:cNvSpPr/>
           <p:nvPr/>
@@ -6424,6 +6311,69 @@
                 <a:latin typeface="Calibri"/>
               </a:rPr>
               <a:t>Live PWA · Gauteng · low-end Android · en / af / zu</a:t>
+            </a:r>
+          </a:p>
+        </p:txBody>
+      </p:sp>
+      <p:pic>
+        <p:nvPicPr>
+          <p:cNvPr id="10" name="Picture 9" descr="homepage-marketplace.png"/>
+          <p:cNvPicPr>
+            <a:picLocks noChangeAspect="1"/>
+          </p:cNvPicPr>
+          <p:nvPr/>
+        </p:nvPicPr>
+        <p:blipFill>
+          <a:blip r:embed="rId3"/>
+          <a:stretch>
+            <a:fillRect/>
+          </a:stretch>
+        </p:blipFill>
+        <p:spPr>
+          <a:xfrm>
+            <a:off x="6812280" y="2376011"/>
+            <a:ext cx="4800600" cy="2700338"/>
+          </a:xfrm>
+          <a:prstGeom prst="rect">
+            <a:avLst/>
+          </a:prstGeom>
+          <a:ln w="12700">
+            <a:solidFill>
+              <a:srgbClr val="C9BCAF"/>
+            </a:solidFill>
+          </a:ln>
+        </p:spPr>
+      </p:pic>
+      <p:sp>
+        <p:nvSpPr>
+          <p:cNvPr id="11" name="TextBox 10"/>
+          <p:cNvSpPr txBox="1"/>
+          <p:nvPr/>
+        </p:nvSpPr>
+        <p:spPr>
+          <a:xfrm>
+            <a:off x="6812280" y="5186076"/>
+            <a:ext cx="4800600" cy="365760"/>
+          </a:xfrm>
+          <a:prstGeom prst="rect">
+            <a:avLst/>
+          </a:prstGeom>
+          <a:noFill/>
+        </p:spPr>
+        <p:txBody>
+          <a:bodyPr wrap="square">
+            <a:spAutoFit/>
+          </a:bodyPr>
+          <a:lstStyle/>
+          <a:p>
+            <a:pPr algn="ctr"/>
+            <a:r>
+              <a:rPr sz="1100" i="1">
+                <a:solidFill>
+                  <a:srgbClr val="D8CFC4"/>
+                </a:solidFill>
+              </a:rPr>
+              <a:t>Live at workitsa.co.za — real jobs, verified workers</a:t>
             </a:r>
           </a:p>
         </p:txBody>
@@ -8924,7 +8874,7 @@
                 </a:solidFill>
                 <a:latin typeface="Calibri"/>
               </a:rPr>
-              <a:t>Save +27 67 748 2643 and send  JOBS</a:t>
+              <a:t>Shown in the demo video below</a:t>
             </a:r>
           </a:p>
         </p:txBody>
@@ -9594,62 +9544,74 @@
           </a:p>
         </p:txBody>
       </p:sp>
-      <p:sp>
-        <p:nvSpPr>
-          <p:cNvPr id="7" name="Rounded Rectangle 6"/>
-          <p:cNvSpPr/>
-          <p:nvPr/>
-        </p:nvSpPr>
+      <p:pic>
+        <p:nvPicPr>
+          <p:cNvPr id="7" name="Picture 6" descr="s7-pulse.png"/>
+          <p:cNvPicPr>
+            <a:picLocks noChangeAspect="1"/>
+          </p:cNvPicPr>
+          <p:nvPr/>
+        </p:nvPicPr>
+        <p:blipFill>
+          <a:blip r:embed="rId3"/>
+          <a:stretch>
+            <a:fillRect/>
+          </a:stretch>
+        </p:blipFill>
         <p:spPr>
           <a:xfrm>
             <a:off x="6812280" y="1783080"/>
-            <a:ext cx="4800600" cy="4206240"/>
-          </a:xfrm>
-          <a:prstGeom prst="roundRect">
-            <a:avLst/>
-          </a:prstGeom>
-          <a:solidFill>
-            <a:srgbClr val="FFFFFF"/>
-          </a:solidFill>
-          <a:ln w="19050">
+            <a:ext cx="4800600" cy="1549644"/>
+          </a:xfrm>
+          <a:prstGeom prst="rect">
+            <a:avLst/>
+          </a:prstGeom>
+          <a:ln w="12700">
             <a:solidFill>
-              <a:srgbClr val="F5DBB5"/>
+              <a:srgbClr val="C9BCAF"/>
             </a:solidFill>
           </a:ln>
-          <a:effectLst/>
-        </p:spPr>
-        <p:style>
-          <a:lnRef idx="1">
-            <a:schemeClr val="accent1"/>
-          </a:lnRef>
-          <a:fillRef idx="3">
-            <a:schemeClr val="accent1"/>
-          </a:fillRef>
-          <a:effectRef idx="2">
-            <a:schemeClr val="accent1"/>
-          </a:effectRef>
-          <a:fontRef idx="minor">
-            <a:schemeClr val="lt1"/>
-          </a:fontRef>
-        </p:style>
-        <p:txBody>
-          <a:bodyPr rtlCol="0" anchor="ctr"/>
-          <a:lstStyle/>
-          <a:p>
-            <a:pPr algn="ctr"/>
-          </a:p>
-        </p:txBody>
-      </p:sp>
-      <p:sp>
-        <p:nvSpPr>
-          <p:cNvPr id="8" name="TextBox 7"/>
+        </p:spPr>
+      </p:pic>
+      <p:pic>
+        <p:nvPicPr>
+          <p:cNvPr id="8" name="Picture 7" descr="s7-jarvis.png"/>
+          <p:cNvPicPr>
+            <a:picLocks noChangeAspect="1"/>
+          </p:cNvPicPr>
+          <p:nvPr/>
+        </p:nvPicPr>
+        <p:blipFill>
+          <a:blip r:embed="rId4"/>
+          <a:stretch>
+            <a:fillRect/>
+          </a:stretch>
+        </p:blipFill>
+        <p:spPr>
+          <a:xfrm>
+            <a:off x="6812280" y="3424100"/>
+            <a:ext cx="4800600" cy="2571750"/>
+          </a:xfrm>
+          <a:prstGeom prst="rect">
+            <a:avLst/>
+          </a:prstGeom>
+          <a:ln w="12700">
+            <a:solidFill>
+              <a:srgbClr val="C9BCAF"/>
+            </a:solidFill>
+          </a:ln>
+        </p:spPr>
+      </p:pic>
+      <p:sp>
+        <p:nvSpPr>
+          <p:cNvPr id="9" name="TextBox 8"/>
           <p:cNvSpPr txBox="1"/>
           <p:nvPr/>
         </p:nvSpPr>
         <p:spPr>
           <a:xfrm>
-            <a:off x="6812280" y="3474720"/>
-            <a:ext cx="4800600" cy="822960"/>
+            <a:off x="6812280" y="6068543"/>
+            <a:ext cx="4800600" cy="274320"/>
           </a:xfrm>
           <a:prstGeom prst="rect">
             <a:avLst/>
@@ -9657,52 +9619,19 @@
           <a:noFill/>
         </p:spPr>
         <p:txBody>
-          <a:bodyPr wrap="square" anchor="ctr">
+          <a:bodyPr wrap="square">
             <a:spAutoFit/>
           </a:bodyPr>
           <a:lstStyle/>
           <a:p>
-            <a:pPr algn="ctr">
-              <a:lnSpc>
-                <a:spcPct val="105000"/>
-              </a:lnSpc>
-              <a:spcBef>
-                <a:spcPts val="0"/>
-              </a:spcBef>
-              <a:spcAft>
-                <a:spcPts val="200"/>
-              </a:spcAft>
-            </a:pPr>
-            <a:r>
-              <a:rPr sz="1300" b="1" i="0">
-                <a:solidFill>
-                  <a:srgbClr val="8A7A6A"/>
-                </a:solidFill>
-                <a:latin typeface="Calibri"/>
-              </a:rPr>
-              <a:t>[ SCREENSHOT ]</a:t>
-            </a:r>
-          </a:p>
-          <a:p>
-            <a:pPr algn="ctr">
-              <a:lnSpc>
-                <a:spcPct val="105000"/>
-              </a:lnSpc>
-              <a:spcBef>
-                <a:spcPts val="0"/>
-              </a:spcBef>
-              <a:spcAft>
-                <a:spcPts val="200"/>
-              </a:spcAft>
-            </a:pPr>
-            <a:r>
-              <a:rPr sz="1100" b="0" i="0">
-                <a:solidFill>
-                  <a:srgbClr val="8A7A6A"/>
-                </a:solidFill>
-                <a:latin typeface="Calibri"/>
-              </a:rPr>
-              <a:t>Live Pulse heatmap + Jarvis chat (/admin)</a:t>
+            <a:pPr algn="ctr"/>
+            <a:r>
+              <a:rPr sz="1000" i="1">
+                <a:solidFill>
+                  <a:srgbClr val="D8CFC4"/>
+                </a:solidFill>
+              </a:rPr>
+              <a:t>Live Pulse + Jarvis — the live-ops brain (/admin)</a:t>
             </a:r>
           </a:p>
         </p:txBody>

</xml_diff>

<commit_message>
deck: refresh S4 to the full WhatsApp arc + fix invisible text on brown slides (S4/S10)
S4 bullets now tell register -> matched -> offer -> hired -> safe -> proof.
Recolored dark-on-dark text on the brown slides (S4, S10) to light (cream
labels / muted descriptions) so it's visible; S6 pill-backed text left as-is.
</commit_message>
<xml_diff>
--- a/Documents/WorkitSA - FNB Hackathon Deck.pptx
+++ b/Documents/WorkitSA - FNB Hackathon Deck.pptx
@@ -5046,7 +5046,7 @@
             <a:r>
               <a:rPr sz="1200" b="0" i="1">
                 <a:solidFill>
-                  <a:srgbClr val="8A7A6A"/>
+                  <a:srgbClr val="D8CFC4"/>
                 </a:solidFill>
                 <a:latin typeface="Calibri"/>
               </a:rPr>
@@ -5100,7 +5100,7 @@
             <a:r>
               <a:rPr sz="1500" b="1" i="0">
                 <a:solidFill>
-                  <a:srgbClr val="1F1612"/>
+                  <a:srgbClr val="FAF4EC"/>
                 </a:solidFill>
                 <a:latin typeface="Calibri"/>
               </a:rPr>
@@ -5109,7 +5109,7 @@
             <a:r>
               <a:rPr sz="1500" b="0" i="0">
                 <a:solidFill>
-                  <a:srgbClr val="4A3A30"/>
+                  <a:srgbClr val="D8CFC4"/>
                 </a:solidFill>
                 <a:latin typeface="Calibri"/>
               </a:rPr>
@@ -5140,7 +5140,7 @@
             <a:r>
               <a:rPr sz="1500" b="1" i="0">
                 <a:solidFill>
-                  <a:srgbClr val="1F1612"/>
+                  <a:srgbClr val="FAF4EC"/>
                 </a:solidFill>
                 <a:latin typeface="Calibri"/>
               </a:rPr>
@@ -5149,7 +5149,7 @@
             <a:r>
               <a:rPr sz="1500" b="0" i="0">
                 <a:solidFill>
-                  <a:srgbClr val="4A3A30"/>
+                  <a:srgbClr val="D8CFC4"/>
                 </a:solidFill>
                 <a:latin typeface="Calibri"/>
               </a:rPr>
@@ -5180,7 +5180,7 @@
             <a:r>
               <a:rPr sz="1500" b="1" i="0">
                 <a:solidFill>
-                  <a:srgbClr val="1F1612"/>
+                  <a:srgbClr val="FAF4EC"/>
                 </a:solidFill>
                 <a:latin typeface="Calibri"/>
               </a:rPr>
@@ -5189,7 +5189,7 @@
             <a:r>
               <a:rPr sz="1500" b="0" i="0">
                 <a:solidFill>
-                  <a:srgbClr val="4A3A30"/>
+                  <a:srgbClr val="D8CFC4"/>
                 </a:solidFill>
                 <a:latin typeface="Calibri"/>
               </a:rPr>
@@ -5278,7 +5278,7 @@
             <a:r>
               <a:rPr sz="1400" b="1" i="0">
                 <a:solidFill>
-                  <a:srgbClr val="1F1612"/>
+                  <a:srgbClr val="FAF4EC"/>
                 </a:solidFill>
                 <a:latin typeface="Calibri"/>
               </a:rPr>
@@ -5300,7 +5300,7 @@
             <a:r>
               <a:rPr sz="1500" b="1" i="0">
                 <a:solidFill>
-                  <a:srgbClr val="1F1612"/>
+                  <a:srgbClr val="FAF4EC"/>
                 </a:solidFill>
                 <a:latin typeface="Calibri"/>
               </a:rPr>
@@ -5322,7 +5322,7 @@
             <a:r>
               <a:rPr sz="1200" b="0" i="0">
                 <a:solidFill>
-                  <a:srgbClr val="1F1612"/>
+                  <a:srgbClr val="FAF4EC"/>
                 </a:solidFill>
                 <a:latin typeface="Calibri"/>
               </a:rPr>
@@ -6619,20 +6619,20 @@
             <a:r>
               <a:rPr sz="1450" b="1" i="0">
                 <a:solidFill>
-                  <a:srgbClr val="1F1612"/>
-                </a:solidFill>
-                <a:latin typeface="Calibri"/>
-              </a:rPr>
-              <a:t>Meet workers where they are.  </a:t>
+                  <a:srgbClr val="FAF4EC"/>
+                </a:solidFill>
+                <a:latin typeface="Calibri"/>
+              </a:rPr>
+              <a:t>Register in a chat.  </a:t>
             </a:r>
             <a:r>
               <a:rPr sz="1450" b="0" i="0">
                 <a:solidFill>
-                  <a:srgbClr val="4A3A30"/>
-                </a:solidFill>
-                <a:latin typeface="Calibri"/>
-              </a:rPr>
-              <a:t>Many can't keep a data-hungry app open. WhatsApp, they already have.</a:t>
+                  <a:srgbClr val="D8CFC4"/>
+                </a:solidFill>
+                <a:latin typeface="Calibri"/>
+              </a:rPr>
+              <a:t>A jobseeker with no app and no data signs up over WhatsApp — name, area, skills, consent.</a:t>
             </a:r>
           </a:p>
           <a:p>
@@ -6659,20 +6659,20 @@
             <a:r>
               <a:rPr sz="1450" b="1" i="0">
                 <a:solidFill>
-                  <a:srgbClr val="1F1612"/>
-                </a:solidFill>
-                <a:latin typeface="Calibri"/>
-              </a:rPr>
-              <a:t>JOBS  </a:t>
+                  <a:srgbClr val="FAF4EC"/>
+                </a:solidFill>
+                <a:latin typeface="Calibri"/>
+              </a:rPr>
+              <a:t>Get matched.  </a:t>
             </a:r>
             <a:r>
               <a:rPr sz="1450" b="0" i="0">
                 <a:solidFill>
-                  <a:srgbClr val="4A3A30"/>
-                </a:solidFill>
-                <a:latin typeface="Calibri"/>
-              </a:rPr>
-              <a:t>→ get the nearby jobs that match you.</a:t>
+                  <a:srgbClr val="D8CFC4"/>
+                </a:solidFill>
+                <a:latin typeface="Calibri"/>
+              </a:rPr>
+              <a:t>We WhatsApp them when a verified job appears nearby, in their line of work.</a:t>
             </a:r>
           </a:p>
           <a:p>
@@ -6699,20 +6699,20 @@
             <a:r>
               <a:rPr sz="1450" b="1" i="0">
                 <a:solidFill>
-                  <a:srgbClr val="1F1612"/>
-                </a:solidFill>
-                <a:latin typeface="Calibri"/>
-              </a:rPr>
-              <a:t>ACCEPT 3  </a:t>
+                  <a:srgbClr val="FAF4EC"/>
+                </a:solidFill>
+                <a:latin typeface="Calibri"/>
+              </a:rPr>
+              <a:t>Find &amp; offer.  </a:t>
             </a:r>
             <a:r>
               <a:rPr sz="1450" b="0" i="0">
                 <a:solidFill>
-                  <a:srgbClr val="4A3A30"/>
-                </a:solidFill>
-                <a:latin typeface="Calibri"/>
-              </a:rPr>
-              <a:t>→ makes an offer to the employer instantly.</a:t>
+                  <a:srgbClr val="D8CFC4"/>
+                </a:solidFill>
+                <a:latin typeface="Calibri"/>
+              </a:rPr>
+              <a:t>Text JOBS to see work; reply a number to apply, or name your own price.</a:t>
             </a:r>
           </a:p>
           <a:p>
@@ -6739,20 +6739,20 @@
             <a:r>
               <a:rPr sz="1450" b="1" i="0">
                 <a:solidFill>
-                  <a:srgbClr val="1F1612"/>
-                </a:solidFill>
-                <a:latin typeface="Calibri"/>
-              </a:rPr>
-              <a:t>ON MY WAY / DONE  </a:t>
+                  <a:srgbClr val="FAF4EC"/>
+                </a:solidFill>
+                <a:latin typeface="Calibri"/>
+              </a:rPr>
+              <a:t>Get hired.  </a:t>
             </a:r>
             <a:r>
               <a:rPr sz="1450" b="0" i="0">
                 <a:solidFill>
-                  <a:srgbClr val="4A3A30"/>
-                </a:solidFill>
-                <a:latin typeface="Calibri"/>
-              </a:rPr>
-              <a:t>→ update the job status by text.</a:t>
+                  <a:srgbClr val="D8CFC4"/>
+                </a:solidFill>
+                <a:latin typeface="Calibri"/>
+              </a:rPr>
+              <a:t>The employer reviews offers and hires with ACCEPT — both sides stay in WhatsApp.</a:t>
             </a:r>
           </a:p>
           <a:p>
@@ -6779,20 +6779,20 @@
             <a:r>
               <a:rPr sz="1450" b="1" i="0">
                 <a:solidFill>
-                  <a:srgbClr val="1F1612"/>
-                </a:solidFill>
-                <a:latin typeface="Calibri"/>
-              </a:rPr>
-              <a:t>Push alerts  </a:t>
+                  <a:srgbClr val="FAF4EC"/>
+                </a:solidFill>
+                <a:latin typeface="Calibri"/>
+              </a:rPr>
+              <a:t>Work safely.  </a:t>
             </a:r>
             <a:r>
               <a:rPr sz="1450" b="0" i="0">
                 <a:solidFill>
-                  <a:srgbClr val="4A3A30"/>
-                </a:solidFill>
-                <a:latin typeface="Calibri"/>
-              </a:rPr>
-              <a:t>when a matching job appears within 10 km of you.</a:t>
+                  <a:srgbClr val="D8CFC4"/>
+                </a:solidFill>
+                <a:latin typeface="Calibri"/>
+              </a:rPr>
+              <a:t>Doorstep start-code, live location check-ins, and SOS straight to our safety team.</a:t>
             </a:r>
           </a:p>
           <a:p>
@@ -6819,20 +6819,20 @@
             <a:r>
               <a:rPr sz="1450" b="1" i="0">
                 <a:solidFill>
-                  <a:srgbClr val="1F1612"/>
-                </a:solidFill>
-                <a:latin typeface="Calibri"/>
-              </a:rPr>
-              <a:t>POPIA-safe.  </a:t>
+                  <a:srgbClr val="FAF4EC"/>
+                </a:solidFill>
+                <a:latin typeface="Calibri"/>
+              </a:rPr>
+              <a:t>Proof of work.  </a:t>
             </a:r>
             <a:r>
               <a:rPr sz="1450" b="0" i="0">
                 <a:solidFill>
-                  <a:srgbClr val="4A3A30"/>
-                </a:solidFill>
-                <a:latin typeface="Calibri"/>
-              </a:rPr>
-              <a:t>Opt-in, free STOP anytime, and no ID or personal data is ever sent over WhatsApp.</a:t>
+                  <a:srgbClr val="D8CFC4"/>
+                </a:solidFill>
+                <a:latin typeface="Calibri"/>
+              </a:rPr>
+              <a:t>Every finished job builds a shareable Work Record — real work readiness, not just a payout.</a:t>
             </a:r>
           </a:p>
         </p:txBody>

</xml_diff>